<commit_message>
Presentación web - slides 5-9 (metodología, resultados 1-3, EPT), carátula, logos y proceso de guardado/traspaso (traspaso.cmd)
</commit_message>
<xml_diff>
--- a/Ejemplo.pptx
+++ b/Ejemplo.pptx
@@ -8,7 +8,7 @@
     <p:notesMasterId r:id="rId15"/>
   </p:notesMasterIdLst>
   <p:sldIdLst>
-    <p:sldId id="256" r:id="rId2"/>
+    <p:sldId id="269" r:id="rId2"/>
     <p:sldId id="257" r:id="rId3"/>
     <p:sldId id="258" r:id="rId4"/>
     <p:sldId id="259" r:id="rId5"/>
@@ -27,15 +27,7 @@
   <p:embeddedFontLst>
     <p:embeddedFont>
       <p:font typeface="Arial Black" panose="020B0A04020102020204" pitchFamily="34" charset="0"/>
-      <p:regular r:id="rId16"/>
-      <p:bold r:id="rId17"/>
-    </p:embeddedFont>
-    <p:embeddedFont>
-      <p:font typeface="Calibri" panose="020F0502020204030204" pitchFamily="34" charset="0"/>
-      <p:regular r:id="rId18"/>
-      <p:bold r:id="rId19"/>
-      <p:italic r:id="rId20"/>
-      <p:boldItalic r:id="rId21"/>
+      <p:bold r:id="rId16"/>
     </p:embeddedFont>
   </p:embeddedFontLst>
   <p:defaultTextStyle>
@@ -267,6 +259,11 @@
       </a:defRPr>
     </a:lvl9pPr>
   </p:defaultTextStyle>
+  <p:extLst>
+    <p:ext uri="{EFAFB233-063F-42B5-8137-9DF3F51BA10A}">
+      <p15:sldGuideLst xmlns:p15="http://schemas.microsoft.com/office/powerpoint/2012/main"/>
+    </p:ext>
+  </p:extLst>
 </p:presentation>
 </file>
 
@@ -1728,7 +1725,7 @@
   <p:cSld>
     <p:spTree>
       <p:nvGrpSpPr>
-        <p:cNvPr id="1" name="Shape 38"/>
+        <p:cNvPr id="1" name="Shape 48"/>
         <p:cNvGrpSpPr/>
         <p:nvPr/>
       </p:nvGrpSpPr>
@@ -1742,7 +1739,7 @@
       </p:grpSpPr>
       <p:sp>
         <p:nvSpPr>
-          <p:cNvPr id="39" name="Google Shape;39;p1:notes"/>
+          <p:cNvPr id="49" name="Google Shape;49;p1:notes"/>
           <p:cNvSpPr txBox="1">
             <a:spLocks noGrp="1"/>
           </p:cNvSpPr>
@@ -1758,10 +1755,6 @@
           <a:prstGeom prst="rect">
             <a:avLst/>
           </a:prstGeom>
-          <a:noFill/>
-          <a:ln>
-            <a:noFill/>
-          </a:ln>
         </p:spPr>
         <p:txBody>
           <a:bodyPr spcFirstLastPara="1" wrap="square" lIns="91425" tIns="45700" rIns="91425" bIns="45700" anchor="t" anchorCtr="0">
@@ -1770,16 +1763,12 @@
           <a:lstStyle/>
           <a:p>
             <a:pPr marL="0" lvl="0" indent="0" algn="l" rtl="0">
-              <a:lnSpc>
-                <a:spcPct val="100000"/>
-              </a:lnSpc>
               <a:spcBef>
                 <a:spcPts val="0"/>
               </a:spcBef>
               <a:spcAft>
                 <a:spcPts val="0"/>
               </a:spcAft>
-              <a:buSzPts val="1400"/>
               <a:buNone/>
             </a:pPr>
             <a:endParaRPr/>
@@ -1788,7 +1777,7 @@
       </p:sp>
       <p:sp>
         <p:nvSpPr>
-          <p:cNvPr id="40" name="Google Shape;40;p1:notes"/>
+          <p:cNvPr id="50" name="Google Shape;50;p1:notes"/>
           <p:cNvSpPr>
             <a:spLocks noGrp="1" noRot="1" noChangeAspect="1"/>
           </p:cNvSpPr>
@@ -1825,16 +1814,6 @@
               </a:path>
             </a:pathLst>
           </a:custGeom>
-          <a:noFill/>
-          <a:ln w="12700" cap="flat" cmpd="sng">
-            <a:solidFill>
-              <a:srgbClr val="000000"/>
-            </a:solidFill>
-            <a:prstDash val="solid"/>
-            <a:round/>
-            <a:headEnd type="none" w="sm" len="sm"/>
-            <a:tailEnd type="none" w="sm" len="sm"/>
-          </a:ln>
         </p:spPr>
       </p:sp>
     </p:spTree>
@@ -5276,17 +5255,9 @@
 <file path=ppt/slides/slide1.xml><?xml version="1.0" encoding="utf-8"?>
 <p:sld xmlns:a="http://schemas.openxmlformats.org/drawingml/2006/main" xmlns:r="http://schemas.openxmlformats.org/officeDocument/2006/relationships" xmlns:p="http://schemas.openxmlformats.org/presentationml/2006/main">
   <p:cSld>
-    <p:bg>
-      <p:bgPr>
-        <a:solidFill>
-          <a:schemeClr val="lt1"/>
-        </a:solidFill>
-        <a:effectLst/>
-      </p:bgPr>
-    </p:bg>
     <p:spTree>
       <p:nvGrpSpPr>
-        <p:cNvPr id="1" name="Shape 41"/>
+        <p:cNvPr id="1" name="Shape 51"/>
         <p:cNvGrpSpPr/>
         <p:nvPr/>
       </p:nvGrpSpPr>
@@ -5300,14 +5271,14 @@
       </p:grpSpPr>
       <p:sp>
         <p:nvSpPr>
-          <p:cNvPr id="42" name="Google Shape;42;p6"/>
+          <p:cNvPr id="52" name="Google Shape;52;p1"/>
           <p:cNvSpPr/>
           <p:nvPr/>
         </p:nvSpPr>
         <p:spPr>
           <a:xfrm>
             <a:off x="0" y="1"/>
-            <a:ext cx="12192000" cy="2493818"/>
+            <a:ext cx="12192000" cy="1828799"/>
           </a:xfrm>
           <a:prstGeom prst="rect">
             <a:avLst/>
@@ -5332,23 +5303,15 @@
           <a:lstStyle/>
           <a:p>
             <a:pPr marL="0" marR="0" lvl="0" indent="0" algn="ctr" rtl="0">
-              <a:lnSpc>
-                <a:spcPct val="100000"/>
-              </a:lnSpc>
               <a:spcBef>
                 <a:spcPts val="0"/>
               </a:spcBef>
               <a:spcAft>
                 <a:spcPts val="0"/>
               </a:spcAft>
-              <a:buClr>
-                <a:srgbClr val="000000"/>
-              </a:buClr>
-              <a:buSzPts val="1800"/>
-              <a:buFont typeface="Arial"/>
               <a:buNone/>
             </a:pPr>
-            <a:endParaRPr sz="1800" b="0" i="0" u="none" strike="noStrike" cap="none">
+            <a:endParaRPr sz="1800">
               <a:solidFill>
                 <a:schemeClr val="lt1"/>
               </a:solidFill>
@@ -5362,7 +5325,7 @@
       </p:sp>
       <p:pic>
         <p:nvPicPr>
-          <p:cNvPr id="43" name="Google Shape;43;p6" descr="Dibujo abstracto de colores&#10;&#10;Descripción generada automáticamente con confianza baja"/>
+          <p:cNvPr id="53" name="Google Shape;53;p1" descr="Dibujo abstracto de colores&#10;&#10;Descripción generada automáticamente con confianza baja"/>
           <p:cNvPicPr preferRelativeResize="0"/>
           <p:nvPr/>
         </p:nvPicPr>
@@ -5389,14 +5352,125 @@
       </p:pic>
       <p:sp>
         <p:nvSpPr>
-          <p:cNvPr id="44" name="Google Shape;44;p6"/>
+          <p:cNvPr id="54" name="Google Shape;54;p1"/>
           <p:cNvSpPr txBox="1"/>
           <p:nvPr/>
         </p:nvSpPr>
         <p:spPr>
           <a:xfrm>
-            <a:off x="1047897" y="2604343"/>
-            <a:ext cx="9816878" cy="523180"/>
+            <a:off x="2005754" y="3087201"/>
+            <a:ext cx="8180419" cy="1200288"/>
+          </a:xfrm>
+          <a:prstGeom prst="rect">
+            <a:avLst/>
+          </a:prstGeom>
+          <a:noFill/>
+          <a:ln>
+            <a:noFill/>
+          </a:ln>
+        </p:spPr>
+        <p:txBody>
+          <a:bodyPr spcFirstLastPara="1" wrap="square" lIns="91425" tIns="45700" rIns="91425" bIns="45700" anchor="t" anchorCtr="0">
+            <a:spAutoFit/>
+          </a:bodyPr>
+          <a:lstStyle/>
+          <a:p>
+            <a:pPr algn="ctr"/>
+            <a:r>
+              <a:rPr lang="es-MX" sz="1800" dirty="0"/>
+              <a:t>Estrategia metodológica de gestión de proyectos basada en controles de ingeniería, orientada a la mejora de las condiciones de seguridad laboral y la prevención de riesgos en proyectos de construcción de la ciudad de Quito, en conformidad con la normativa ecuatoriana vigente entre 2024 y 2026</a:t>
+            </a:r>
+            <a:endParaRPr lang="es-EC" sz="1800" dirty="0"/>
+          </a:p>
+        </p:txBody>
+      </p:sp>
+      <p:pic>
+        <p:nvPicPr>
+          <p:cNvPr id="55" name="Google Shape;55;p1" descr="Imagen que contiene dibujo, reloj&#10;&#10;Descripción generada automáticamente"/>
+          <p:cNvPicPr preferRelativeResize="0"/>
+          <p:nvPr/>
+        </p:nvPicPr>
+        <p:blipFill rotWithShape="1">
+          <a:blip r:embed="rId4">
+            <a:alphaModFix/>
+          </a:blip>
+          <a:srcRect/>
+          <a:stretch/>
+        </p:blipFill>
+        <p:spPr>
+          <a:xfrm>
+            <a:off x="4222496" y="489718"/>
+            <a:ext cx="3886644" cy="830997"/>
+          </a:xfrm>
+          <a:prstGeom prst="rect">
+            <a:avLst/>
+          </a:prstGeom>
+          <a:noFill/>
+          <a:ln>
+            <a:noFill/>
+          </a:ln>
+        </p:spPr>
+      </p:pic>
+      <p:sp>
+        <p:nvSpPr>
+          <p:cNvPr id="56" name="Google Shape;56;p1"/>
+          <p:cNvSpPr txBox="1"/>
+          <p:nvPr/>
+        </p:nvSpPr>
+        <p:spPr>
+          <a:xfrm>
+            <a:off x="3479301" y="4556286"/>
+            <a:ext cx="5234730" cy="338514"/>
+          </a:xfrm>
+          <a:prstGeom prst="rect">
+            <a:avLst/>
+          </a:prstGeom>
+          <a:noFill/>
+          <a:ln>
+            <a:noFill/>
+          </a:ln>
+        </p:spPr>
+        <p:txBody>
+          <a:bodyPr spcFirstLastPara="1" wrap="square" lIns="91425" tIns="45700" rIns="91425" bIns="45700" anchor="t" anchorCtr="0">
+            <a:spAutoFit/>
+          </a:bodyPr>
+          <a:lstStyle/>
+          <a:p>
+            <a:pPr marL="0" marR="0" lvl="0" indent="0" algn="ctr" rtl="0">
+              <a:spcBef>
+                <a:spcPts val="0"/>
+              </a:spcBef>
+              <a:spcAft>
+                <a:spcPts val="0"/>
+              </a:spcAft>
+              <a:buNone/>
+            </a:pPr>
+            <a:r>
+              <a:rPr lang="en-US" sz="1600" b="1" dirty="0">
+                <a:solidFill>
+                  <a:srgbClr val="006E49"/>
+                </a:solidFill>
+                <a:latin typeface="Arial"/>
+                <a:ea typeface="Arial"/>
+                <a:cs typeface="Arial"/>
+                <a:sym typeface="Arial"/>
+              </a:rPr>
+              <a:t>DOCTORADO EN DIRECCIÓN DE PROYECTOS</a:t>
+            </a:r>
+            <a:endParaRPr dirty="0"/>
+          </a:p>
+        </p:txBody>
+      </p:sp>
+      <p:sp>
+        <p:nvSpPr>
+          <p:cNvPr id="57" name="Google Shape;57;p1"/>
+          <p:cNvSpPr/>
+          <p:nvPr/>
+        </p:nvSpPr>
+        <p:spPr>
+          <a:xfrm>
+            <a:off x="3747668" y="4976384"/>
+            <a:ext cx="4836300" cy="350825"/>
           </a:xfrm>
           <a:prstGeom prst="rect">
             <a:avLst/>
@@ -5414,7 +5488,7 @@
           <a:p>
             <a:pPr marL="0" marR="0" lvl="0" indent="0" algn="ctr" rtl="0">
               <a:lnSpc>
-                <a:spcPct val="100000"/>
+                <a:spcPct val="120000"/>
               </a:lnSpc>
               <a:spcBef>
                 <a:spcPts val="0"/>
@@ -5425,116 +5499,56 @@
               <a:buNone/>
             </a:pPr>
             <a:r>
-              <a:rPr lang="en-US" sz="2800" b="0" i="0" u="none" strike="noStrike" cap="none">
+              <a:rPr lang="en-US" sz="1400" b="1" dirty="0" err="1">
                 <a:solidFill>
-                  <a:srgbClr val="4C4A4F"/>
+                  <a:srgbClr val="595959"/>
                 </a:solidFill>
                 <a:latin typeface="Arial"/>
                 <a:ea typeface="Arial"/>
                 <a:cs typeface="Arial"/>
                 <a:sym typeface="Arial"/>
               </a:rPr>
-              <a:t>TÍTULO DE LA TESIS</a:t>
-            </a:r>
-            <a:endParaRPr sz="1200" b="0" i="0" u="none" strike="noStrike" cap="none">
-              <a:solidFill>
-                <a:srgbClr val="000000"/>
-              </a:solidFill>
-              <a:latin typeface="Arial"/>
-              <a:ea typeface="Arial"/>
-              <a:cs typeface="Arial"/>
-              <a:sym typeface="Arial"/>
-            </a:endParaRPr>
-          </a:p>
-        </p:txBody>
-      </p:sp>
-      <p:pic>
-        <p:nvPicPr>
-          <p:cNvPr id="45" name="Google Shape;45;p6" descr="Imagen que contiene dibujo, reloj&#10;&#10;Descripción generada automáticamente"/>
-          <p:cNvPicPr preferRelativeResize="0"/>
-          <p:nvPr/>
-        </p:nvPicPr>
-        <p:blipFill rotWithShape="1">
-          <a:blip r:embed="rId4">
-            <a:alphaModFix/>
-          </a:blip>
-          <a:srcRect/>
-          <a:stretch/>
-        </p:blipFill>
-        <p:spPr>
-          <a:xfrm>
-            <a:off x="4222496" y="1018446"/>
-            <a:ext cx="3886644" cy="830997"/>
-          </a:xfrm>
-          <a:prstGeom prst="rect">
-            <a:avLst/>
-          </a:prstGeom>
-          <a:noFill/>
-          <a:ln>
-            <a:noFill/>
-          </a:ln>
-        </p:spPr>
-      </p:pic>
-      <p:sp>
-        <p:nvSpPr>
-          <p:cNvPr id="46" name="Google Shape;46;p6"/>
-          <p:cNvSpPr txBox="1"/>
-          <p:nvPr/>
-        </p:nvSpPr>
-        <p:spPr>
-          <a:xfrm>
-            <a:off x="3230614" y="4629414"/>
-            <a:ext cx="5610300" cy="338700"/>
-          </a:xfrm>
-          <a:prstGeom prst="rect">
-            <a:avLst/>
-          </a:prstGeom>
-          <a:noFill/>
-          <a:ln>
-            <a:noFill/>
-          </a:ln>
-        </p:spPr>
-        <p:txBody>
-          <a:bodyPr spcFirstLastPara="1" wrap="square" lIns="91425" tIns="45700" rIns="91425" bIns="45700" anchor="t" anchorCtr="0">
-            <a:spAutoFit/>
-          </a:bodyPr>
-          <a:lstStyle/>
-          <a:p>
-            <a:pPr marL="0" marR="0" lvl="0" indent="0" algn="ctr" rtl="0">
-              <a:lnSpc>
-                <a:spcPct val="100000"/>
-              </a:lnSpc>
-              <a:spcBef>
-                <a:spcPts val="0"/>
-              </a:spcBef>
-              <a:spcAft>
-                <a:spcPts val="0"/>
-              </a:spcAft>
-              <a:buNone/>
-            </a:pPr>
-            <a:r>
-              <a:rPr lang="en-US" sz="1600" b="1" dirty="0">
-                <a:solidFill>
-                  <a:srgbClr val="006E49"/>
-                </a:solidFill>
-              </a:rPr>
-              <a:t>DOCTORADO </a:t>
+              <a:t>Candidato</a:t>
             </a:r>
             <a:r>
-              <a:rPr lang="en-US" sz="1600" b="1" i="0" u="none" strike="noStrike" cap="none" dirty="0">
+              <a:rPr lang="en-US" sz="1400" b="1" dirty="0">
                 <a:solidFill>
-                  <a:srgbClr val="006E49"/>
+                  <a:srgbClr val="595959"/>
                 </a:solidFill>
                 <a:latin typeface="Arial"/>
                 <a:ea typeface="Arial"/>
                 <a:cs typeface="Arial"/>
                 <a:sym typeface="Arial"/>
               </a:rPr>
-              <a:t>EN …….</a:t>
+              <a:t>: Jorge Alexander </a:t>
             </a:r>
-            <a:endParaRPr sz="1400" b="0" i="0" u="none" strike="noStrike" cap="none" dirty="0">
+            <a:r>
+              <a:rPr lang="en-US" sz="1400" b="1" dirty="0" err="1">
+                <a:solidFill>
+                  <a:srgbClr val="595959"/>
+                </a:solidFill>
+                <a:latin typeface="Arial"/>
+                <a:ea typeface="Arial"/>
+                <a:cs typeface="Arial"/>
+                <a:sym typeface="Arial"/>
+              </a:rPr>
+              <a:t>Bucheli</a:t>
+            </a:r>
+            <a:r>
+              <a:rPr lang="en-US" sz="1400" b="1" dirty="0">
+                <a:solidFill>
+                  <a:srgbClr val="595959"/>
+                </a:solidFill>
+                <a:latin typeface="Arial"/>
+                <a:ea typeface="Arial"/>
+                <a:cs typeface="Arial"/>
+                <a:sym typeface="Arial"/>
+              </a:rPr>
+              <a:t> García</a:t>
+            </a:r>
+            <a:endParaRPr sz="1400" b="1" dirty="0">
               <a:solidFill>
-                <a:srgbClr val="000000"/>
+                <a:srgbClr val="595959"/>
               </a:solidFill>
               <a:latin typeface="Arial"/>
               <a:ea typeface="Arial"/>
@@ -5546,60 +5560,7 @@
       </p:sp>
       <p:sp>
         <p:nvSpPr>
-          <p:cNvPr id="47" name="Google Shape;47;p6"/>
-          <p:cNvSpPr/>
-          <p:nvPr/>
-        </p:nvSpPr>
-        <p:spPr>
-          <a:xfrm>
-            <a:off x="4004614" y="5303552"/>
-            <a:ext cx="4836300" cy="387758"/>
-          </a:xfrm>
-          <a:prstGeom prst="rect">
-            <a:avLst/>
-          </a:prstGeom>
-          <a:noFill/>
-          <a:ln>
-            <a:noFill/>
-          </a:ln>
-        </p:spPr>
-        <p:txBody>
-          <a:bodyPr spcFirstLastPara="1" wrap="square" lIns="91425" tIns="45700" rIns="91425" bIns="45700" anchor="t" anchorCtr="0">
-            <a:noAutofit/>
-          </a:bodyPr>
-          <a:lstStyle/>
-          <a:p>
-            <a:pPr marL="0" marR="0" lvl="0" indent="0" algn="ctr" rtl="0">
-              <a:lnSpc>
-                <a:spcPct val="120000"/>
-              </a:lnSpc>
-              <a:spcBef>
-                <a:spcPts val="0"/>
-              </a:spcBef>
-              <a:spcAft>
-                <a:spcPts val="0"/>
-              </a:spcAft>
-              <a:buNone/>
-            </a:pPr>
-            <a:r>
-              <a:rPr lang="en-US" sz="1600" b="1" i="0" u="none" strike="noStrike" cap="none">
-                <a:solidFill>
-                  <a:srgbClr val="595959"/>
-                </a:solidFill>
-                <a:latin typeface="Arial"/>
-                <a:ea typeface="Arial"/>
-                <a:cs typeface="Arial"/>
-                <a:sym typeface="Arial"/>
-              </a:rPr>
-              <a:t>PRESENTA: …..</a:t>
-            </a:r>
-            <a:endParaRPr/>
-          </a:p>
-        </p:txBody>
-      </p:sp>
-      <p:sp>
-        <p:nvSpPr>
-          <p:cNvPr id="48" name="Google Shape;48;p6"/>
+          <p:cNvPr id="58" name="Google Shape;58;p1"/>
           <p:cNvSpPr/>
           <p:nvPr/>
         </p:nvSpPr>
@@ -5613,7 +5574,7 @@
           </a:prstGeom>
           <a:solidFill>
             <a:srgbClr val="FF0000">
-              <a:alpha val="76470"/>
+              <a:alpha val="76862"/>
             </a:srgbClr>
           </a:solidFill>
           <a:ln>
@@ -5627,23 +5588,15 @@
           <a:lstStyle/>
           <a:p>
             <a:pPr marL="0" marR="0" lvl="0" indent="0" algn="ctr" rtl="0">
-              <a:lnSpc>
-                <a:spcPct val="100000"/>
-              </a:lnSpc>
               <a:spcBef>
                 <a:spcPts val="0"/>
               </a:spcBef>
               <a:spcAft>
                 <a:spcPts val="0"/>
               </a:spcAft>
-              <a:buClr>
-                <a:srgbClr val="000000"/>
-              </a:buClr>
-              <a:buSzPts val="1800"/>
-              <a:buFont typeface="Arial"/>
               <a:buNone/>
             </a:pPr>
-            <a:endParaRPr sz="1800" b="0" i="0" u="none" strike="noStrike" cap="none">
+            <a:endParaRPr sz="1800">
               <a:solidFill>
                 <a:schemeClr val="lt1"/>
               </a:solidFill>
@@ -5657,7 +5610,7 @@
       </p:sp>
       <p:sp>
         <p:nvSpPr>
-          <p:cNvPr id="49" name="Google Shape;49;p6"/>
+          <p:cNvPr id="59" name="Google Shape;59;p1"/>
           <p:cNvSpPr/>
           <p:nvPr/>
         </p:nvSpPr>
@@ -5671,7 +5624,7 @@
           </a:prstGeom>
           <a:solidFill>
             <a:srgbClr val="497F64">
-              <a:alpha val="76470"/>
+              <a:alpha val="76862"/>
             </a:srgbClr>
           </a:solidFill>
           <a:ln>
@@ -5685,23 +5638,15 @@
           <a:lstStyle/>
           <a:p>
             <a:pPr marL="0" marR="0" lvl="0" indent="0" algn="ctr" rtl="0">
-              <a:lnSpc>
-                <a:spcPct val="100000"/>
-              </a:lnSpc>
               <a:spcBef>
                 <a:spcPts val="0"/>
               </a:spcBef>
               <a:spcAft>
                 <a:spcPts val="0"/>
               </a:spcAft>
-              <a:buClr>
-                <a:srgbClr val="000000"/>
-              </a:buClr>
-              <a:buSzPts val="1800"/>
-              <a:buFont typeface="Arial"/>
               <a:buNone/>
             </a:pPr>
-            <a:endParaRPr sz="1800" b="0" i="0" u="none" strike="noStrike" cap="none">
+            <a:endParaRPr sz="1800">
               <a:solidFill>
                 <a:srgbClr val="006E49"/>
               </a:solidFill>
@@ -5715,7 +5660,7 @@
       </p:sp>
       <p:sp>
         <p:nvSpPr>
-          <p:cNvPr id="50" name="Google Shape;50;p6"/>
+          <p:cNvPr id="60" name="Google Shape;60;p1"/>
           <p:cNvSpPr/>
           <p:nvPr/>
         </p:nvSpPr>
@@ -5729,7 +5674,7 @@
           </a:prstGeom>
           <a:solidFill>
             <a:srgbClr val="0C0C0C">
-              <a:alpha val="76470"/>
+              <a:alpha val="76862"/>
             </a:srgbClr>
           </a:solidFill>
           <a:ln>
@@ -5743,23 +5688,15 @@
           <a:lstStyle/>
           <a:p>
             <a:pPr marL="0" marR="0" lvl="0" indent="0" algn="ctr" rtl="0">
-              <a:lnSpc>
-                <a:spcPct val="100000"/>
-              </a:lnSpc>
               <a:spcBef>
                 <a:spcPts val="0"/>
               </a:spcBef>
               <a:spcAft>
                 <a:spcPts val="0"/>
               </a:spcAft>
-              <a:buClr>
-                <a:srgbClr val="000000"/>
-              </a:buClr>
-              <a:buSzPts val="1800"/>
-              <a:buFont typeface="Arial"/>
               <a:buNone/>
             </a:pPr>
-            <a:endParaRPr sz="1800" b="0" i="0" u="none" strike="noStrike" cap="none">
+            <a:endParaRPr sz="1800">
               <a:solidFill>
                 <a:srgbClr val="006E49"/>
               </a:solidFill>
@@ -5773,7 +5710,7 @@
       </p:sp>
       <p:grpSp>
         <p:nvGrpSpPr>
-          <p:cNvPr id="51" name="Google Shape;51;p6"/>
+          <p:cNvPr id="61" name="Google Shape;61;p1"/>
           <p:cNvGrpSpPr/>
           <p:nvPr/>
         </p:nvGrpSpPr>
@@ -5787,7 +5724,7 @@
         </p:grpSpPr>
         <p:sp>
           <p:nvSpPr>
-            <p:cNvPr id="52" name="Google Shape;52;p6"/>
+            <p:cNvPr id="62" name="Google Shape;62;p1"/>
             <p:cNvSpPr/>
             <p:nvPr/>
           </p:nvSpPr>
@@ -5813,23 +5750,15 @@
             <a:lstStyle/>
             <a:p>
               <a:pPr marL="0" marR="0" lvl="0" indent="0" algn="ctr" rtl="0">
-                <a:lnSpc>
-                  <a:spcPct val="100000"/>
-                </a:lnSpc>
                 <a:spcBef>
                   <a:spcPts val="0"/>
                 </a:spcBef>
                 <a:spcAft>
                   <a:spcPts val="0"/>
                 </a:spcAft>
-                <a:buClr>
-                  <a:srgbClr val="000000"/>
-                </a:buClr>
-                <a:buSzPts val="1800"/>
-                <a:buFont typeface="Arial"/>
                 <a:buNone/>
               </a:pPr>
-              <a:endParaRPr sz="1800" b="0" i="0" u="none" strike="noStrike" cap="none">
+              <a:endParaRPr sz="1800">
                 <a:solidFill>
                   <a:schemeClr val="lt1"/>
                 </a:solidFill>
@@ -5843,7 +5772,7 @@
         </p:sp>
         <p:sp>
           <p:nvSpPr>
-            <p:cNvPr id="53" name="Google Shape;53;p6"/>
+            <p:cNvPr id="63" name="Google Shape;63;p1"/>
             <p:cNvSpPr txBox="1"/>
             <p:nvPr/>
           </p:nvSpPr>
@@ -5869,24 +5798,16 @@
             <a:lstStyle/>
             <a:p>
               <a:pPr marL="0" marR="0" lvl="0" indent="0" algn="ctr" rtl="0">
-                <a:lnSpc>
-                  <a:spcPct val="100000"/>
-                </a:lnSpc>
                 <a:spcBef>
                   <a:spcPts val="0"/>
                 </a:spcBef>
                 <a:spcAft>
                   <a:spcPts val="0"/>
                 </a:spcAft>
-                <a:buClr>
-                  <a:srgbClr val="000000"/>
-                </a:buClr>
-                <a:buSzPts val="1000"/>
-                <a:buFont typeface="Arial"/>
                 <a:buNone/>
               </a:pPr>
               <a:r>
-                <a:rPr lang="en-US" sz="1000" b="1" i="0" u="none" strike="noStrike" cap="none">
+                <a:rPr lang="en-US" sz="1000" b="1" dirty="0">
                   <a:solidFill>
                     <a:schemeClr val="lt1"/>
                   </a:solidFill>
@@ -5897,7 +5818,7 @@
                 </a:rPr>
                 <a:t>ETIQUETA</a:t>
               </a:r>
-              <a:endParaRPr sz="1400" b="1" i="0" u="none" strike="noStrike" cap="none">
+              <a:endParaRPr sz="1400" b="1" dirty="0">
                 <a:solidFill>
                   <a:schemeClr val="lt1"/>
                 </a:solidFill>
@@ -5910,6 +5831,143 @@
           </p:txBody>
         </p:sp>
       </p:grpSp>
+      <p:sp>
+        <p:nvSpPr>
+          <p:cNvPr id="4" name="Google Shape;135;p3">
+            <a:extLst>
+              <a:ext uri="{FF2B5EF4-FFF2-40B4-BE49-F238E27FC236}">
+                <a16:creationId xmlns:a16="http://schemas.microsoft.com/office/drawing/2014/main" id="{397D2DAF-F106-4F32-8FCA-42EC03355CF4}"/>
+              </a:ext>
+            </a:extLst>
+          </p:cNvPr>
+          <p:cNvSpPr txBox="1"/>
+          <p:nvPr/>
+        </p:nvSpPr>
+        <p:spPr>
+          <a:xfrm>
+            <a:off x="3351904" y="2165633"/>
+            <a:ext cx="5492209" cy="523180"/>
+          </a:xfrm>
+          <a:prstGeom prst="rect">
+            <a:avLst/>
+          </a:prstGeom>
+          <a:noFill/>
+          <a:ln>
+            <a:noFill/>
+          </a:ln>
+        </p:spPr>
+        <p:txBody>
+          <a:bodyPr spcFirstLastPara="1" wrap="square" lIns="91425" tIns="45700" rIns="91425" bIns="45700" anchor="t" anchorCtr="0">
+            <a:spAutoFit/>
+          </a:bodyPr>
+          <a:lstStyle/>
+          <a:p>
+            <a:pPr marL="0" marR="0" lvl="0" indent="0" algn="ctr" rtl="0">
+              <a:spcBef>
+                <a:spcPts val="0"/>
+              </a:spcBef>
+              <a:spcAft>
+                <a:spcPts val="0"/>
+              </a:spcAft>
+              <a:buNone/>
+            </a:pPr>
+            <a:r>
+              <a:rPr lang="es-EC" sz="2800" dirty="0">
+                <a:solidFill>
+                  <a:srgbClr val="4C4A4F"/>
+                </a:solidFill>
+                <a:latin typeface="Arial"/>
+                <a:ea typeface="Arial"/>
+                <a:cs typeface="Arial"/>
+                <a:sym typeface="Arial"/>
+              </a:rPr>
+              <a:t>Presentación Tesis Doctoral</a:t>
+            </a:r>
+            <a:endParaRPr sz="1050" dirty="0"/>
+          </a:p>
+        </p:txBody>
+      </p:sp>
+      <p:sp>
+        <p:nvSpPr>
+          <p:cNvPr id="6" name="CuadroTexto 5">
+            <a:extLst>
+              <a:ext uri="{FF2B5EF4-FFF2-40B4-BE49-F238E27FC236}">
+                <a16:creationId xmlns:a16="http://schemas.microsoft.com/office/drawing/2014/main" id="{9E486E78-FF38-8685-8A5B-239EFB86C48A}"/>
+              </a:ext>
+            </a:extLst>
+          </p:cNvPr>
+          <p:cNvSpPr txBox="1"/>
+          <p:nvPr/>
+        </p:nvSpPr>
+        <p:spPr>
+          <a:xfrm>
+            <a:off x="3103837" y="5358971"/>
+            <a:ext cx="6123962" cy="586892"/>
+          </a:xfrm>
+          <a:prstGeom prst="rect">
+            <a:avLst/>
+          </a:prstGeom>
+          <a:noFill/>
+        </p:spPr>
+        <p:txBody>
+          <a:bodyPr wrap="square">
+            <a:spAutoFit/>
+          </a:bodyPr>
+          <a:lstStyle/>
+          <a:p>
+            <a:pPr algn="ctr">
+              <a:lnSpc>
+                <a:spcPct val="120000"/>
+              </a:lnSpc>
+              <a:tabLst>
+                <a:tab pos="1170305" algn="l"/>
+              </a:tabLst>
+            </a:pPr>
+            <a:r>
+              <a:rPr lang="es-EC" b="1" dirty="0">
+                <a:solidFill>
+                  <a:srgbClr val="595959"/>
+                </a:solidFill>
+              </a:rPr>
+              <a:t>Asesora:</a:t>
+            </a:r>
+          </a:p>
+          <a:p>
+            <a:pPr algn="ctr">
+              <a:lnSpc>
+                <a:spcPct val="120000"/>
+              </a:lnSpc>
+              <a:tabLst>
+                <a:tab pos="1170305" algn="l"/>
+              </a:tabLst>
+            </a:pPr>
+            <a:r>
+              <a:rPr lang="es-EC" b="1" dirty="0">
+                <a:solidFill>
+                  <a:srgbClr val="595959"/>
+                </a:solidFill>
+              </a:rPr>
+              <a:t>Dra. Julia Ayuso, </a:t>
+            </a:r>
+            <a:r>
+              <a:rPr lang="es-EC" b="1" dirty="0" err="1">
+                <a:solidFill>
+                  <a:srgbClr val="595959"/>
+                </a:solidFill>
+              </a:rPr>
+              <a:t>Ph.D</a:t>
+            </a:r>
+            <a:r>
+              <a:rPr lang="es-EC" b="1" dirty="0">
+                <a:solidFill>
+                  <a:srgbClr val="595959"/>
+                </a:solidFill>
+              </a:rPr>
+              <a:t>.</a:t>
+            </a:r>
+          </a:p>
+        </p:txBody>
+      </p:sp>
     </p:spTree>
   </p:cSld>
   <p:clrMapOvr>

</xml_diff>